<commit_message>
Fitness Prediction Final Version
</commit_message>
<xml_diff>
--- a/presentation/FitnessLevel_DataMining Presentation.pptx
+++ b/presentation/FitnessLevel_DataMining Presentation.pptx
@@ -2777,7 +2777,7 @@
                 <a:ea typeface="Calibri" pitchFamily="34" charset="-122"/>
                 <a:cs typeface="Calibri" pitchFamily="34" charset="-120"/>
               </a:rPr>
-              <a:t>Team:  </a:t>
+              <a:t>Elaborated by:  </a:t>
             </a:r>
             <a:r>
               <a:rPr lang="en-US" sz="1300" dirty="0">
@@ -2788,7 +2788,7 @@
                 <a:ea typeface="Calibri" pitchFamily="34" charset="-122"/>
                 <a:cs typeface="Calibri" pitchFamily="34" charset="-120"/>
               </a:rPr>
-              <a:t>Amine Bessaad  •  Haitham Maatar  •  Jasser Sghaier</a:t>
+              <a:t>•  Haitham Maatar  • </a:t>
             </a:r>
             <a:endParaRPr lang="en-US" sz="1300" dirty="0"/>
           </a:p>

</xml_diff>